<commit_message>
Update delivery timeline to a three-week internal pilot
Replaces the "four-week, one-developer, AI-assisted pilot" line on
the Delivery Scope/Roadmap and Delivery Plan slides (both the
technical and management decks, plus the Markdown source) with a
"Three-Week Internal Pilot" section: a functional version is
delivered for internal testing within three weeks, followed by a
separate production-readiness phase after successful testing and
management approval.

Co-authored-by: Claude <noreply@anthropic.com>
</commit_message>
<xml_diff>
--- a/docs/presentation/Tiger-CS-Application-Architecture-Management.pptx
+++ b/docs/presentation/Tiger-CS-Application-Architecture-Management.pptx
@@ -7014,12 +7014,12 @@
         </p:nvSpPr>
         <p:spPr>
           <a:xfrm>
-            <a:off x="457200" y="3246120"/>
-            <a:ext cx="11277295" cy="777240"/>
+            <a:off x="457200" y="3063240"/>
+            <a:ext cx="11277295" cy="1280160"/>
           </a:xfrm>
           <a:prstGeom prst="roundRect">
             <a:avLst>
-              <a:gd name="adj" fmla="val 11765"/>
+              <a:gd name="adj" fmla="val 7143"/>
             </a:avLst>
           </a:prstGeom>
           <a:solidFill>
@@ -7048,8 +7048,8 @@
         </p:nvSpPr>
         <p:spPr>
           <a:xfrm>
-            <a:off x="777240" y="3246120"/>
-            <a:ext cx="10637215" cy="777240"/>
+            <a:off x="777240" y="3200400"/>
+            <a:ext cx="10637215" cy="365760"/>
           </a:xfrm>
           <a:prstGeom prst="rect">
             <a:avLst/>
@@ -7061,25 +7061,50 @@
           <a:bodyPr wrap="square" lIns="0" tIns="0" rIns="0" bIns="0" rtlCol="0" anchor="ctr"/>
           <a:lstStyle/>
           <a:p>
-            <a:pPr algn="l" indent="0" marL="0">
-              <a:buNone/>
-            </a:pPr>
-            <a:r>
-              <a:rPr lang="en-US" sz="1800" b="1" dirty="0">
+            <a:pPr indent="0" marL="0">
+              <a:buNone/>
+            </a:pPr>
+            <a:r>
+              <a:rPr lang="en-US" sz="1700" b="1" dirty="0">
                 <a:solidFill>
                   <a:srgbClr val="1C2B4A"/>
                 </a:solidFill>
-                <a:latin typeface="Calibri" pitchFamily="34" charset="0"/>
-                <a:ea typeface="Calibri" pitchFamily="34" charset="-122"/>
-                <a:cs typeface="Calibri" pitchFamily="34" charset="-120"/>
-              </a:rPr>
-              <a:t>Delivery model:  </a:t>
-            </a:r>
-            <a:pPr algn="l" indent="0" marL="0">
-              <a:buNone/>
-            </a:pPr>
-            <a:r>
-              <a:rPr lang="en-US" sz="1800" dirty="0">
+                <a:latin typeface="Cambria" pitchFamily="34" charset="0"/>
+                <a:ea typeface="Cambria" pitchFamily="34" charset="-122"/>
+                <a:cs typeface="Cambria" pitchFamily="34" charset="-120"/>
+              </a:rPr>
+              <a:t>Three-Week Internal Pilot</a:t>
+            </a:r>
+            <a:endParaRPr lang="en-US" sz="1700" dirty="0"/>
+          </a:p>
+        </p:txBody>
+      </p:sp>
+      <p:sp>
+        <p:nvSpPr>
+          <p:cNvPr id="16" name="Text 14"/>
+          <p:cNvSpPr/>
+          <p:nvPr/>
+        </p:nvSpPr>
+        <p:spPr>
+          <a:xfrm>
+            <a:off x="777240" y="3584448"/>
+            <a:ext cx="10637215" cy="685800"/>
+          </a:xfrm>
+          <a:prstGeom prst="rect">
+            <a:avLst/>
+          </a:prstGeom>
+          <a:noFill/>
+          <a:ln/>
+        </p:spPr>
+        <p:txBody>
+          <a:bodyPr wrap="square" lIns="0" tIns="0" rIns="0" bIns="0" rtlCol="0" anchor="t"/>
+          <a:lstStyle/>
+          <a:p>
+            <a:pPr indent="0" marL="0">
+              <a:buNone/>
+            </a:pPr>
+            <a:r>
+              <a:rPr lang="en-US" sz="1400" dirty="0">
                 <a:solidFill>
                   <a:srgbClr val="3A3F44"/>
                 </a:solidFill>
@@ -7087,26 +7112,26 @@
                 <a:ea typeface="Calibri" pitchFamily="34" charset="-122"/>
                 <a:cs typeface="Calibri" pitchFamily="34" charset="-120"/>
               </a:rPr>
-              <a:t>a four-week internal pilot</a:t>
-            </a:r>
-            <a:endParaRPr lang="en-US" sz="1800" dirty="0"/>
-          </a:p>
-        </p:txBody>
-      </p:sp>
-      <p:sp>
-        <p:nvSpPr>
-          <p:cNvPr id="16" name="Shape 14"/>
-          <p:cNvSpPr/>
-          <p:nvPr/>
-        </p:nvSpPr>
-        <p:spPr>
-          <a:xfrm>
-            <a:off x="457200" y="4343400"/>
-            <a:ext cx="11277295" cy="1508760"/>
+              <a:t>A functional version will be delivered for internal testing within three weeks, developed by one developer with AI-assisted development. Following successful testing and management approval, a separate production-readiness phase will prepare the system for official go-live.</a:t>
+            </a:r>
+            <a:endParaRPr lang="en-US" sz="1400" dirty="0"/>
+          </a:p>
+        </p:txBody>
+      </p:sp>
+      <p:sp>
+        <p:nvSpPr>
+          <p:cNvPr id="17" name="Shape 15"/>
+          <p:cNvSpPr/>
+          <p:nvPr/>
+        </p:nvSpPr>
+        <p:spPr>
+          <a:xfrm>
+            <a:off x="457200" y="4526280"/>
+            <a:ext cx="11277295" cy="1417320"/>
           </a:xfrm>
           <a:prstGeom prst="roundRect">
             <a:avLst>
-              <a:gd name="adj" fmla="val 6061"/>
+              <a:gd name="adj" fmla="val 6452"/>
             </a:avLst>
           </a:prstGeom>
           <a:solidFill>
@@ -7129,13 +7154,13 @@
       </p:sp>
       <p:sp>
         <p:nvSpPr>
-          <p:cNvPr id="17" name="Shape 15"/>
-          <p:cNvSpPr/>
-          <p:nvPr/>
-        </p:nvSpPr>
-        <p:spPr>
-          <a:xfrm>
-            <a:off x="777240" y="4645152"/>
+          <p:cNvPr id="18" name="Shape 16"/>
+          <p:cNvSpPr/>
+          <p:nvPr/>
+        </p:nvSpPr>
+        <p:spPr>
+          <a:xfrm>
+            <a:off x="777240" y="4782312"/>
             <a:ext cx="640080" cy="640080"/>
           </a:xfrm>
           <a:prstGeom prst="ellipse">
@@ -7149,13 +7174,13 @@
       </p:sp>
       <p:sp>
         <p:nvSpPr>
-          <p:cNvPr id="18" name="Text 16"/>
-          <p:cNvSpPr/>
-          <p:nvPr/>
-        </p:nvSpPr>
-        <p:spPr>
-          <a:xfrm>
-            <a:off x="777240" y="4645152"/>
+          <p:cNvPr id="19" name="Text 17"/>
+          <p:cNvSpPr/>
+          <p:nvPr/>
+        </p:nvSpPr>
+        <p:spPr>
+          <a:xfrm>
+            <a:off x="777240" y="4782312"/>
             <a:ext cx="640080" cy="640080"/>
           </a:xfrm>
           <a:prstGeom prst="rect">
@@ -7188,13 +7213,13 @@
       </p:sp>
       <p:sp>
         <p:nvSpPr>
-          <p:cNvPr id="19" name="Text 17"/>
-          <p:cNvSpPr/>
-          <p:nvPr/>
-        </p:nvSpPr>
-        <p:spPr>
-          <a:xfrm>
-            <a:off x="1600200" y="4526280"/>
+          <p:cNvPr id="20" name="Text 18"/>
+          <p:cNvSpPr/>
+          <p:nvPr/>
+        </p:nvSpPr>
+        <p:spPr>
+          <a:xfrm>
+            <a:off x="1600200" y="4663440"/>
             <a:ext cx="9814255" cy="457200"/>
           </a:xfrm>
           <a:prstGeom prst="rect">
@@ -7227,14 +7252,14 @@
       </p:sp>
       <p:sp>
         <p:nvSpPr>
-          <p:cNvPr id="20" name="Text 18"/>
-          <p:cNvSpPr/>
-          <p:nvPr/>
-        </p:nvSpPr>
-        <p:spPr>
-          <a:xfrm>
-            <a:off x="1600200" y="4983480"/>
-            <a:ext cx="9814255" cy="777240"/>
+          <p:cNvPr id="21" name="Text 19"/>
+          <p:cNvSpPr/>
+          <p:nvPr/>
+        </p:nvSpPr>
+        <p:spPr>
+          <a:xfrm>
+            <a:off x="1600200" y="5120640"/>
+            <a:ext cx="9814255" cy="731520"/>
           </a:xfrm>
           <a:prstGeom prst="rect">
             <a:avLst/>
@@ -7266,7 +7291,7 @@
       </p:sp>
       <p:sp>
         <p:nvSpPr>
-          <p:cNvPr id="21" name="Text 19"/>
+          <p:cNvPr id="22" name="Text 20"/>
           <p:cNvSpPr/>
           <p:nvPr/>
         </p:nvSpPr>
@@ -7305,7 +7330,7 @@
       </p:sp>
       <p:sp>
         <p:nvSpPr>
-          <p:cNvPr id="22" name="Text 20"/>
+          <p:cNvPr id="23" name="Text 21"/>
           <p:cNvSpPr/>
           <p:nvPr/>
         </p:nvSpPr>

</xml_diff>